<commit_message>
Add infographic for Minna 1 Bab 1; use plain names, no honorific prefix
Replace "Sdr. Nama" with just the name in the Bab 1 grammar examples
(slide deck and cheatsheet) so translations read "Andi bukan
mahasiswa" instead of "Sdr. Andi bukan mahasiswa". The Japanese さん
honorific itself is unaffected since that is the grammar point of
pattern 6.

Co-Authored-By: Claude Sonnet 5 <noreply@anthropic.com>
Claude-Session: https://claude.ai/code/session_01R2r5CpV1mHfrPgo3fPN6U9
</commit_message>
<xml_diff>
--- a/Modul Minna 1/Bab 1/26. Minna 1 Tata Bahasa Bab 1 - Slide.pptx
+++ b/Modul Minna 1/Bab 1/26. Minna 1 Tata Bahasa Bab 1 - Slide.pptx
@@ -3008,7 +3008,7 @@
                 <a:ea typeface="Arial" pitchFamily="34" charset="-122"/>
                 <a:cs typeface="Arial" pitchFamily="34" charset="-120"/>
               </a:rPr>
-              <a:t>Sdr. Andi bukan mahasiswa.</a:t>
+              <a:t>Andi bukan mahasiswa.</a:t>
             </a:r>
             <a:endParaRPr lang="en-US" sz="950" dirty="0"/>
           </a:p>
@@ -3658,7 +3658,7 @@
                 <a:ea typeface="Arial" pitchFamily="34" charset="-122"/>
                 <a:cs typeface="Arial" pitchFamily="34" charset="-120"/>
               </a:rPr>
-              <a:t>Apakah Sdr. Budi orang Indonesia?</a:t>
+              <a:t>Apakah Budi orang Indonesia?</a:t>
             </a:r>
             <a:endParaRPr lang="en-US" sz="950" dirty="0"/>
           </a:p>
@@ -4252,7 +4252,7 @@
                 <a:ea typeface="Arial" pitchFamily="34" charset="-122"/>
                 <a:cs typeface="Arial" pitchFamily="34" charset="-120"/>
               </a:rPr>
-              <a:t>Sdr. Budi pegawai perusahaan.</a:t>
+              <a:t>Budi pegawai perusahaan.</a:t>
             </a:r>
             <a:endParaRPr lang="en-US" sz="950" dirty="0"/>
           </a:p>
@@ -4846,7 +4846,7 @@
                 <a:ea typeface="Arial" pitchFamily="34" charset="-122"/>
                 <a:cs typeface="Arial" pitchFamily="34" charset="-120"/>
               </a:rPr>
-              <a:t>Sdr. Budi pegawai (dari) JBridge Center.</a:t>
+              <a:t>Budi pegawai (dari) JBridge Center.</a:t>
             </a:r>
             <a:endParaRPr lang="en-US" sz="950" dirty="0"/>
           </a:p>
@@ -5205,7 +5205,7 @@
                 <a:ea typeface="Arial" pitchFamily="34" charset="-122"/>
                 <a:cs typeface="Arial" pitchFamily="34" charset="-120"/>
               </a:rPr>
-              <a:t>さん  ditempel di belakang nama orang (mirip Bapak/Ibu/Sdr.). JANGAN dipakai untuk diri sendiri. Untuk anak kecil, biasa pakai  〜ちゃん .</a:t>
+              <a:t>さん  ditempel di belakang nama orang (mirip Bapak/Ibu). JANGAN dipakai untuk diri sendiri. Untuk anak kecil, biasa pakai  〜ちゃん .</a:t>
             </a:r>
             <a:endParaRPr lang="en-US" sz="1200" dirty="0"/>
           </a:p>
@@ -5384,7 +5384,7 @@
                 <a:ea typeface="Arial" pitchFamily="34" charset="-122"/>
                 <a:cs typeface="Arial" pitchFamily="34" charset="-120"/>
               </a:rPr>
-              <a:t>Beliau (adalah) Sdr. Budi.</a:t>
+              <a:t>Beliau (adalah) Budi.</a:t>
             </a:r>
             <a:endParaRPr lang="en-US" sz="950" dirty="0"/>
           </a:p>

</xml_diff>